<commit_message>
Point deck slides at Canvas pages instead of repo paths
Decks 3, 4, 6, and 7 told students to see `resources/License-Cheat-Sheet.md`,
`assignments/Discovery-Notes.md`, `resources/PRD-Reference.md`, and
`rubrics.md`. Those were repo paths back when the documents were repo files;
now they are Canvas pages, and a student reading the slide has nothing to open.

Slides now name the destination the way a student reaches it -- "Canvas ->
Course Resources", "the Assignment Rubrics page". Two presenter notes fixed the
same way, since they are read live while pointing students somewhere.

Rebuilt all four and linted clean: no overflow, no low-contrast text. Scanned
the text of all nine decks afterward; none names a file path any more.

Co-Authored-By: Claude Opus 5 (1M context) <noreply@anthropic.com>
Claude-Session: https://claude.ai/code/session_015BdLGtCS1Dkqvh3DzVXGc7
</commit_message>
<xml_diff>
--- a/canvas_material/lectures/powerpoint/Session03-OpenSource.pptx
+++ b/canvas_material/lectures/powerpoint/Session03-OpenSource.pptx
@@ -4368,7 +4368,7 @@
                 <a:ea typeface="Calibri" pitchFamily="34" charset="-122"/>
                 <a:cs typeface="Calibri" pitchFamily="34" charset="-120"/>
               </a:rPr>
-              <a:t>Reference: resources/License-Cheat-Sheet.md · choosealicense.com</a:t>
+              <a:t>Reference: License Cheat Sheet (Canvas → Course Resources) · choosealicense.com</a:t>
             </a:r>
             <a:endParaRPr lang="en-US" sz="1400" dirty="0"/>
           </a:p>
@@ -9665,7 +9665,7 @@
                 <a:ea typeface="Calibri" pitchFamily="34" charset="-122"/>
                 <a:cs typeface="Calibri" pitchFamily="34" charset="-120"/>
               </a:rPr>
-              <a:t>Full one-pager: resources/License-Cheat-Sheet.md — includes BSD, LGPL, MPL, and public domain.</a:t>
+              <a:t>Full one-pager: the License Cheat Sheet on Canvas — includes BSD, LGPL, MPL, and public domain.</a:t>
             </a:r>
             <a:endParaRPr lang="en-US" sz="1300" dirty="0"/>
           </a:p>

</xml_diff>

<commit_message>
Updates for lectures 3 & 4 and adding ability to add animations to slide decks.
</commit_message>
<xml_diff>
--- a/canvas_material/lectures/powerpoint/Session03-OpenSource.pptx
+++ b/canvas_material/lectures/powerpoint/Session03-OpenSource.pptx
@@ -1042,7 +1042,7 @@
           <a:p>
             <a:r>
               <a:rPr lang="en-US" dirty="0"/>
-              <a:t>Draw the benefits out of the room where you can: contributors, feedback and trust ("many eyes"), reuse and reach, and longevity plus a public portfolio. Then use the navy discussion card to keep it honest — what's actually scary about building in public, whether "given enough eyeballs, all bugs are shallow" holds up, and the key founder question: why would anyone contribute to YOUR project? Let them wrestle with that last one. ~4-5 min.</a:t>
+              <a:t>Draw the benefits out of the room where you can: contributors, feedback and trust ("many eyes"), reuse and reach, and longevity plus a public portfolio. Then click to reveal the navy discussion card and use it to keep things honest — what's actually scary about building in public, whether "given enough eyeballs, all bugs are shallow" holds up, and the key founder question: why would anyone contribute to YOUR project? Let them wrestle with that last one. ~4-5 min.</a:t>
             </a:r>
             <a:endParaRPr lang="en-US" dirty="0"/>
           </a:p>
@@ -1482,7 +1482,7 @@
           <a:p>
             <a:r>
               <a:rPr lang="en-US" dirty="0"/>
-              <a:t>Define governance plainly: the rules and expectations that let strangers contribute safely — the license, the code of conduct, the contribution process, and who decides. Without it, even great code stays a solo repo. Use the contributor's-eye view to make it visceral: a would-be helper asks "do I know how to contribute? what's expected of me? am I even allowed to use this?" — good governance answers all three before they have to ask. ~3 min.</a:t>
+              <a:t>Define governance plainly: the rules and expectations that let strangers contribute safely — the license, the code of conduct, the contribution process, and who decides. Without it, even great code stays a solo repo. Click to reveal the contributor's-eye view and use it to make it visceral: a would-be helper asks "do I know how to contribute? what's expected of me? am I even allowed to use this?" — good governance answers all three before they have to ask. ~3 min.</a:t>
             </a:r>
             <a:endParaRPr lang="en-US" dirty="0"/>
           </a:p>
@@ -5829,7 +5829,7 @@
       </p:sp>
       <p:sp>
         <p:nvSpPr>
-          <p:cNvPr id="21" name="Shape 15"/>
+          <p:cNvPr id="21" name="click-1"/>
           <p:cNvSpPr/>
           <p:nvPr/>
         </p:nvSpPr>
@@ -5858,7 +5858,7 @@
       </p:sp>
       <p:sp>
         <p:nvSpPr>
-          <p:cNvPr id="22" name="Shape 16"/>
+          <p:cNvPr id="22" name="click-1"/>
           <p:cNvSpPr/>
           <p:nvPr/>
         </p:nvSpPr>
@@ -5878,7 +5878,7 @@
       </p:sp>
       <p:pic>
         <p:nvPicPr>
-          <p:cNvPr id="23" name="Image 4" descr="preencoded.png">    </p:cNvPr>
+          <p:cNvPr id="23" name="click-1" descr="preencoded.png">    </p:cNvPr>
           <p:cNvPicPr>
             <a:picLocks noChangeAspect="1"/>
           </p:cNvPicPr>
@@ -5902,7 +5902,7 @@
       </p:pic>
       <p:sp>
         <p:nvSpPr>
-          <p:cNvPr id="24" name="Text 17"/>
+          <p:cNvPr id="24" name="click-1"/>
           <p:cNvSpPr/>
           <p:nvPr/>
         </p:nvSpPr>
@@ -5941,7 +5941,7 @@
       </p:sp>
       <p:sp>
         <p:nvSpPr>
-          <p:cNvPr id="25" name="Text 18"/>
+          <p:cNvPr id="25" name="click-1"/>
           <p:cNvSpPr/>
           <p:nvPr/>
         </p:nvSpPr>
@@ -6110,6 +6110,195 @@
   <p:clrMapOvr>
     <a:masterClrMapping/>
   </p:clrMapOvr>
+  <p:timing>
+    <p:tnLst>
+      <p:par>
+        <p:cTn id="1" dur="indefinite" restart="never" nodeType="tmRoot">
+          <p:childTnLst>
+            <p:seq concurrent="1" nextAc="seek">
+              <p:cTn id="2" dur="indefinite" nodeType="mainSeq">
+                <p:childTnLst>
+                  <p:par>
+                    <p:cTn id="3" fill="hold">
+                      <p:stCondLst>
+                        <p:cond delay="indefinite"/>
+                      </p:stCondLst>
+                      <p:childTnLst>
+                        <p:par>
+                          <p:cTn id="4" fill="hold">
+                            <p:stCondLst>
+                              <p:cond delay="0"/>
+                            </p:stCondLst>
+                            <p:childTnLst>
+                              <p:par>
+                                <p:cTn id="6" presetID="1" presetClass="entr" presetSubtype="0" fill="hold" grpId="0" nodeType="clickEffect">
+                                  <p:stCondLst>
+                                    <p:cond delay="0"/>
+                                  </p:stCondLst>
+                                  <p:childTnLst>
+                                    <p:set>
+                                      <p:cBhvr>
+                                        <p:cTn id="5" dur="1" fill="hold">
+                                          <p:stCondLst>
+                                            <p:cond delay="0"/>
+                                          </p:stCondLst>
+                                        </p:cTn>
+                                        <p:tgtEl>
+                                          <p:spTgt spid="21"/>
+                                        </p:tgtEl>
+                                        <p:attrNameLst>
+                                          <p:attrName>style.visibility</p:attrName>
+                                        </p:attrNameLst>
+                                      </p:cBhvr>
+                                      <p:to>
+                                        <p:strVal val="visible"/>
+                                      </p:to>
+                                    </p:set>
+                                  </p:childTnLst>
+                                </p:cTn>
+                              </p:par>
+                              <p:par>
+                                <p:cTn id="8" presetID="1" presetClass="entr" presetSubtype="0" fill="hold" grpId="0" nodeType="withEffect">
+                                  <p:stCondLst>
+                                    <p:cond delay="0"/>
+                                  </p:stCondLst>
+                                  <p:childTnLst>
+                                    <p:set>
+                                      <p:cBhvr>
+                                        <p:cTn id="7" dur="1" fill="hold">
+                                          <p:stCondLst>
+                                            <p:cond delay="0"/>
+                                          </p:stCondLst>
+                                        </p:cTn>
+                                        <p:tgtEl>
+                                          <p:spTgt spid="22"/>
+                                        </p:tgtEl>
+                                        <p:attrNameLst>
+                                          <p:attrName>style.visibility</p:attrName>
+                                        </p:attrNameLst>
+                                      </p:cBhvr>
+                                      <p:to>
+                                        <p:strVal val="visible"/>
+                                      </p:to>
+                                    </p:set>
+                                  </p:childTnLst>
+                                </p:cTn>
+                              </p:par>
+                              <p:par>
+                                <p:cTn id="10" presetID="1" presetClass="entr" presetSubtype="0" fill="hold" nodeType="withEffect">
+                                  <p:stCondLst>
+                                    <p:cond delay="0"/>
+                                  </p:stCondLst>
+                                  <p:childTnLst>
+                                    <p:set>
+                                      <p:cBhvr>
+                                        <p:cTn id="9" dur="1" fill="hold">
+                                          <p:stCondLst>
+                                            <p:cond delay="0"/>
+                                          </p:stCondLst>
+                                        </p:cTn>
+                                        <p:tgtEl>
+                                          <p:spTgt spid="23"/>
+                                        </p:tgtEl>
+                                        <p:attrNameLst>
+                                          <p:attrName>style.visibility</p:attrName>
+                                        </p:attrNameLst>
+                                      </p:cBhvr>
+                                      <p:to>
+                                        <p:strVal val="visible"/>
+                                      </p:to>
+                                    </p:set>
+                                  </p:childTnLst>
+                                </p:cTn>
+                              </p:par>
+                              <p:par>
+                                <p:cTn id="12" presetID="1" presetClass="entr" presetSubtype="0" fill="hold" grpId="0" nodeType="withEffect">
+                                  <p:stCondLst>
+                                    <p:cond delay="0"/>
+                                  </p:stCondLst>
+                                  <p:childTnLst>
+                                    <p:set>
+                                      <p:cBhvr>
+                                        <p:cTn id="11" dur="1" fill="hold">
+                                          <p:stCondLst>
+                                            <p:cond delay="0"/>
+                                          </p:stCondLst>
+                                        </p:cTn>
+                                        <p:tgtEl>
+                                          <p:spTgt spid="24"/>
+                                        </p:tgtEl>
+                                        <p:attrNameLst>
+                                          <p:attrName>style.visibility</p:attrName>
+                                        </p:attrNameLst>
+                                      </p:cBhvr>
+                                      <p:to>
+                                        <p:strVal val="visible"/>
+                                      </p:to>
+                                    </p:set>
+                                  </p:childTnLst>
+                                </p:cTn>
+                              </p:par>
+                              <p:par>
+                                <p:cTn id="14" presetID="1" presetClass="entr" presetSubtype="0" fill="hold" grpId="0" nodeType="withEffect">
+                                  <p:stCondLst>
+                                    <p:cond delay="0"/>
+                                  </p:stCondLst>
+                                  <p:childTnLst>
+                                    <p:set>
+                                      <p:cBhvr>
+                                        <p:cTn id="13" dur="1" fill="hold">
+                                          <p:stCondLst>
+                                            <p:cond delay="0"/>
+                                          </p:stCondLst>
+                                        </p:cTn>
+                                        <p:tgtEl>
+                                          <p:spTgt spid="25"/>
+                                        </p:tgtEl>
+                                        <p:attrNameLst>
+                                          <p:attrName>style.visibility</p:attrName>
+                                        </p:attrNameLst>
+                                      </p:cBhvr>
+                                      <p:to>
+                                        <p:strVal val="visible"/>
+                                      </p:to>
+                                    </p:set>
+                                  </p:childTnLst>
+                                </p:cTn>
+                              </p:par>
+                            </p:childTnLst>
+                          </p:cTn>
+                        </p:par>
+                      </p:childTnLst>
+                    </p:cTn>
+                  </p:par>
+                </p:childTnLst>
+              </p:cTn>
+              <p:prevCondLst>
+                <p:cond evt="onPrev" delay="0">
+                  <p:tgtEl>
+                    <p:sldTgt/>
+                  </p:tgtEl>
+                </p:cond>
+              </p:prevCondLst>
+              <p:nextCondLst>
+                <p:cond evt="onNext" delay="0">
+                  <p:tgtEl>
+                    <p:sldTgt/>
+                  </p:tgtEl>
+                </p:cond>
+              </p:nextCondLst>
+            </p:seq>
+          </p:childTnLst>
+        </p:cTn>
+      </p:par>
+    </p:tnLst>
+    <p:bldLst>
+      <p:bldP spid="21" grpId="0" animBg="1"/>
+      <p:bldP spid="22" grpId="0" animBg="1"/>
+      <p:bldP spid="24" grpId="0" animBg="1"/>
+      <p:bldP spid="25" grpId="0" animBg="1"/>
+    </p:bldLst>
+  </p:timing>
 </p:sld>
 </file>
 
@@ -10809,7 +10998,7 @@
       </p:sp>
       <p:sp>
         <p:nvSpPr>
-          <p:cNvPr id="9" name="Shape 6"/>
+          <p:cNvPr id="9" name="click-1"/>
           <p:cNvSpPr/>
           <p:nvPr/>
         </p:nvSpPr>
@@ -10838,7 +11027,7 @@
       </p:sp>
       <p:sp>
         <p:nvSpPr>
-          <p:cNvPr id="10" name="Shape 7"/>
+          <p:cNvPr id="10" name="click-1"/>
           <p:cNvSpPr/>
           <p:nvPr/>
         </p:nvSpPr>
@@ -10858,7 +11047,7 @@
       </p:sp>
       <p:pic>
         <p:nvPicPr>
-          <p:cNvPr id="11" name="Image 1" descr="preencoded.png">    </p:cNvPr>
+          <p:cNvPr id="11" name="click-1" descr="preencoded.png">    </p:cNvPr>
           <p:cNvPicPr>
             <a:picLocks noChangeAspect="1"/>
           </p:cNvPicPr>
@@ -10882,7 +11071,7 @@
       </p:pic>
       <p:sp>
         <p:nvSpPr>
-          <p:cNvPr id="12" name="Text 8"/>
+          <p:cNvPr id="12" name="click-1"/>
           <p:cNvSpPr/>
           <p:nvPr/>
         </p:nvSpPr>
@@ -10921,7 +11110,7 @@
       </p:sp>
       <p:sp>
         <p:nvSpPr>
-          <p:cNvPr id="13" name="Text 9"/>
+          <p:cNvPr id="13" name="click-1"/>
           <p:cNvSpPr/>
           <p:nvPr/>
         </p:nvSpPr>
@@ -11044,6 +11233,195 @@
   <p:clrMapOvr>
     <a:masterClrMapping/>
   </p:clrMapOvr>
+  <p:timing>
+    <p:tnLst>
+      <p:par>
+        <p:cTn id="1" dur="indefinite" restart="never" nodeType="tmRoot">
+          <p:childTnLst>
+            <p:seq concurrent="1" nextAc="seek">
+              <p:cTn id="2" dur="indefinite" nodeType="mainSeq">
+                <p:childTnLst>
+                  <p:par>
+                    <p:cTn id="3" fill="hold">
+                      <p:stCondLst>
+                        <p:cond delay="indefinite"/>
+                      </p:stCondLst>
+                      <p:childTnLst>
+                        <p:par>
+                          <p:cTn id="4" fill="hold">
+                            <p:stCondLst>
+                              <p:cond delay="0"/>
+                            </p:stCondLst>
+                            <p:childTnLst>
+                              <p:par>
+                                <p:cTn id="6" presetID="1" presetClass="entr" presetSubtype="0" fill="hold" grpId="0" nodeType="clickEffect">
+                                  <p:stCondLst>
+                                    <p:cond delay="0"/>
+                                  </p:stCondLst>
+                                  <p:childTnLst>
+                                    <p:set>
+                                      <p:cBhvr>
+                                        <p:cTn id="5" dur="1" fill="hold">
+                                          <p:stCondLst>
+                                            <p:cond delay="0"/>
+                                          </p:stCondLst>
+                                        </p:cTn>
+                                        <p:tgtEl>
+                                          <p:spTgt spid="9"/>
+                                        </p:tgtEl>
+                                        <p:attrNameLst>
+                                          <p:attrName>style.visibility</p:attrName>
+                                        </p:attrNameLst>
+                                      </p:cBhvr>
+                                      <p:to>
+                                        <p:strVal val="visible"/>
+                                      </p:to>
+                                    </p:set>
+                                  </p:childTnLst>
+                                </p:cTn>
+                              </p:par>
+                              <p:par>
+                                <p:cTn id="8" presetID="1" presetClass="entr" presetSubtype="0" fill="hold" grpId="0" nodeType="withEffect">
+                                  <p:stCondLst>
+                                    <p:cond delay="0"/>
+                                  </p:stCondLst>
+                                  <p:childTnLst>
+                                    <p:set>
+                                      <p:cBhvr>
+                                        <p:cTn id="7" dur="1" fill="hold">
+                                          <p:stCondLst>
+                                            <p:cond delay="0"/>
+                                          </p:stCondLst>
+                                        </p:cTn>
+                                        <p:tgtEl>
+                                          <p:spTgt spid="10"/>
+                                        </p:tgtEl>
+                                        <p:attrNameLst>
+                                          <p:attrName>style.visibility</p:attrName>
+                                        </p:attrNameLst>
+                                      </p:cBhvr>
+                                      <p:to>
+                                        <p:strVal val="visible"/>
+                                      </p:to>
+                                    </p:set>
+                                  </p:childTnLst>
+                                </p:cTn>
+                              </p:par>
+                              <p:par>
+                                <p:cTn id="10" presetID="1" presetClass="entr" presetSubtype="0" fill="hold" nodeType="withEffect">
+                                  <p:stCondLst>
+                                    <p:cond delay="0"/>
+                                  </p:stCondLst>
+                                  <p:childTnLst>
+                                    <p:set>
+                                      <p:cBhvr>
+                                        <p:cTn id="9" dur="1" fill="hold">
+                                          <p:stCondLst>
+                                            <p:cond delay="0"/>
+                                          </p:stCondLst>
+                                        </p:cTn>
+                                        <p:tgtEl>
+                                          <p:spTgt spid="11"/>
+                                        </p:tgtEl>
+                                        <p:attrNameLst>
+                                          <p:attrName>style.visibility</p:attrName>
+                                        </p:attrNameLst>
+                                      </p:cBhvr>
+                                      <p:to>
+                                        <p:strVal val="visible"/>
+                                      </p:to>
+                                    </p:set>
+                                  </p:childTnLst>
+                                </p:cTn>
+                              </p:par>
+                              <p:par>
+                                <p:cTn id="12" presetID="1" presetClass="entr" presetSubtype="0" fill="hold" grpId="0" nodeType="withEffect">
+                                  <p:stCondLst>
+                                    <p:cond delay="0"/>
+                                  </p:stCondLst>
+                                  <p:childTnLst>
+                                    <p:set>
+                                      <p:cBhvr>
+                                        <p:cTn id="11" dur="1" fill="hold">
+                                          <p:stCondLst>
+                                            <p:cond delay="0"/>
+                                          </p:stCondLst>
+                                        </p:cTn>
+                                        <p:tgtEl>
+                                          <p:spTgt spid="12"/>
+                                        </p:tgtEl>
+                                        <p:attrNameLst>
+                                          <p:attrName>style.visibility</p:attrName>
+                                        </p:attrNameLst>
+                                      </p:cBhvr>
+                                      <p:to>
+                                        <p:strVal val="visible"/>
+                                      </p:to>
+                                    </p:set>
+                                  </p:childTnLst>
+                                </p:cTn>
+                              </p:par>
+                              <p:par>
+                                <p:cTn id="14" presetID="1" presetClass="entr" presetSubtype="0" fill="hold" grpId="0" nodeType="withEffect">
+                                  <p:stCondLst>
+                                    <p:cond delay="0"/>
+                                  </p:stCondLst>
+                                  <p:childTnLst>
+                                    <p:set>
+                                      <p:cBhvr>
+                                        <p:cTn id="13" dur="1" fill="hold">
+                                          <p:stCondLst>
+                                            <p:cond delay="0"/>
+                                          </p:stCondLst>
+                                        </p:cTn>
+                                        <p:tgtEl>
+                                          <p:spTgt spid="13"/>
+                                        </p:tgtEl>
+                                        <p:attrNameLst>
+                                          <p:attrName>style.visibility</p:attrName>
+                                        </p:attrNameLst>
+                                      </p:cBhvr>
+                                      <p:to>
+                                        <p:strVal val="visible"/>
+                                      </p:to>
+                                    </p:set>
+                                  </p:childTnLst>
+                                </p:cTn>
+                              </p:par>
+                            </p:childTnLst>
+                          </p:cTn>
+                        </p:par>
+                      </p:childTnLst>
+                    </p:cTn>
+                  </p:par>
+                </p:childTnLst>
+              </p:cTn>
+              <p:prevCondLst>
+                <p:cond evt="onPrev" delay="0">
+                  <p:tgtEl>
+                    <p:sldTgt/>
+                  </p:tgtEl>
+                </p:cond>
+              </p:prevCondLst>
+              <p:nextCondLst>
+                <p:cond evt="onNext" delay="0">
+                  <p:tgtEl>
+                    <p:sldTgt/>
+                  </p:tgtEl>
+                </p:cond>
+              </p:nextCondLst>
+            </p:seq>
+          </p:childTnLst>
+        </p:cTn>
+      </p:par>
+    </p:tnLst>
+    <p:bldLst>
+      <p:bldP spid="9" grpId="0" animBg="1"/>
+      <p:bldP spid="10" grpId="0" animBg="1"/>
+      <p:bldP spid="12" grpId="0" animBg="1"/>
+      <p:bldP spid="13" grpId="0" animBg="1"/>
+    </p:bldLst>
+  </p:timing>
 </p:sld>
 </file>
 

</xml_diff>